<commit_message>
docs(slides): add Slide 10 showing full Fragment 1 Greek letters scale and open prizes
</commit_message>
<xml_diff>
--- a/Kintsugi_Ecuaciones_Fisicas.pptx
+++ b/Kintsugi_Ecuaciones_Fisicas.pptx
@@ -14,6 +14,7 @@
     <p:sldId id="262" r:id="rId8"/>
     <p:sldId id="263" r:id="rId9"/>
     <p:sldId id="264" r:id="rId10"/>
+    <p:sldId id="265" r:id="rId11"/>
   </p:sldIdLst>
   <p:sldSz cx="12192000" cy="6858000"/>
   <p:notesSz cx="6858000" cy="9144000"/>
@@ -93,6 +94,45 @@
 </p:sld>
 </file>
 
+<file path=ppt/slides/slide10.xml><?xml version="1.0" encoding="utf-8"?>
+<p:sld xmlns:a="http://schemas.openxmlformats.org/drawingml/2006/main" xmlns:r="http://schemas.openxmlformats.org/officeDocument/2006/relationships" xmlns:p="http://schemas.openxmlformats.org/presentationml/2006/main">
+  <p:cSld>
+    <p:spTree>
+      <p:nvGrpSpPr>
+        <p:cNvPr id="1" name=""/>
+        <p:cNvGrpSpPr/>
+        <p:nvPr/>
+      </p:nvGrpSpPr>
+      <p:grpSpPr/>
+      <p:pic>
+        <p:nvPicPr>
+          <p:cNvPr id="2" name="SlideImage"/>
+          <p:cNvPicPr>
+            <a:picLocks noChangeAspect="1"/>
+          </p:cNvPicPr>
+          <p:nvPr/>
+        </p:nvPicPr>
+        <p:blipFill>
+          <a:blip r:embed="rId2"/>
+          <a:stretch>
+            <a:fillRect/>
+          </a:stretch>
+        </p:blipFill>
+        <p:spPr>
+          <a:xfrm>
+            <a:off x="0" y="0"/>
+            <a:ext cx="12192000" cy="6858000"/>
+          </a:xfrm>
+          <a:prstGeom prst="rect">
+            <a:avLst/>
+          </a:prstGeom>
+        </p:spPr>
+      </p:pic>
+    </p:spTree>
+  </p:cSld>
+</p:sld>
+</file>
+
 <file path=ppt/slides/slide2.xml><?xml version="1.0" encoding="utf-8"?>
 <p:sld xmlns:a="http://schemas.openxmlformats.org/drawingml/2006/main" xmlns:r="http://schemas.openxmlformats.org/officeDocument/2006/relationships" xmlns:p="http://schemas.openxmlformats.org/presentationml/2006/main">
   <p:cSld>

</xml_diff>